<commit_message>
Nhúng font Inter và Be Vietnam Pro vào slide (v9)
Máy không cài hai font này mở bằng PowerPoint thì chữ tiếng Việt có dấu
ở các chữ đậm hiện thành ô vuông. Nội dung slide giữ nguyên như v8.

Co-Authored-By: Claude Opus 5.5 (1M context) <noreply@anthropic.com>
Claude-Session: https://claude.ai/code/session_01GubYFV997ERjgVho2NpEjU
</commit_message>
<xml_diff>
--- a/presentation/PRM323-Lab2-SE190533-slides.pptx
+++ b/presentation/PRM323-Lab2-SE190533-slides.pptx
@@ -1,6 +1,6 @@
 
 <file path=ppt/presentation.xml><?xml version="1.0" encoding="utf-8"?>
-<p:presentation xmlns:a="http://schemas.openxmlformats.org/drawingml/2006/main" xmlns:r="http://schemas.openxmlformats.org/officeDocument/2006/relationships" xmlns:p="http://schemas.openxmlformats.org/presentationml/2006/main" saveSubsetFonts="1" autoCompressPictures="0">
+<p:presentation xmlns:a="http://schemas.openxmlformats.org/drawingml/2006/main" xmlns:r="http://schemas.openxmlformats.org/officeDocument/2006/relationships" xmlns:p="http://schemas.openxmlformats.org/presentationml/2006/main" embedTrueTypeFonts="1" saveSubsetFonts="1" autoCompressPictures="0">
   <p:sldMasterIdLst>
     <p:sldMasterId id="2147483648" r:id="rId1"/>
   </p:sldMasterIdLst>
@@ -23,6 +23,26 @@
   </p:notesMasterIdLst>
   <p:sldSz cx="12192000" cy="6858000"/>
   <p:notesSz cx="6858000" cy="12192000"/>
+  <p:embeddedFontLst>
+    <p:embeddedFont>
+      <p:font typeface="Inter" pitchFamily="2" charset="0"/>
+      <p:regular r:id="rId19"/>
+      <p:bold r:id="rId20"/>
+    </p:embeddedFont>
+    <p:embeddedFont>
+      <p:font typeface="Inter Medium" pitchFamily="2" charset="0"/>
+      <p:regular r:id="rId21"/>
+    </p:embeddedFont>
+    <p:embeddedFont>
+      <p:font typeface="Inter SemiBold" pitchFamily="2" charset="0"/>
+      <p:regular r:id="rId22"/>
+    </p:embeddedFont>
+    <p:embeddedFont>
+      <p:font typeface="Be Vietnam Pro" pitchFamily="2" charset="0"/>
+      <p:regular r:id="rId23"/>
+      <p:bold r:id="rId24"/>
+    </p:embeddedFont>
+  </p:embeddedFontLst>
   <p:defaultTextStyle>
     <a:lvl1pPr marL="0" algn="l" defTabSz="914400" rtl="0" eaLnBrk="1" latinLnBrk="0" hangingPunct="1">
       <a:defRPr sz="1800" kern="1200">

</xml_diff>